<commit_message>
Fix upcoming-events filter under-fetch; refine soutenance deck
</commit_message>
<xml_diff>
--- a/docs/presentation.pptx
+++ b/docs/presentation.pptx
@@ -5130,7 +5130,7 @@
                 </a:solidFill>
                 <a:latin typeface="Calibri"/>
               </a:rPr>
-              <a:t>81 tests automatisés (unitaires + API).</a:t>
+              <a:t>82 tests automatisés (unitaires + API).</a:t>
             </a:r>
           </a:p>
           <a:p>
@@ -8145,7 +8145,7 @@
                 </a:solidFill>
                 <a:latin typeface="Consolas"/>
               </a:rPr>
-              <a:t>├── tests/       81 tests (10 fichiers)</a:t>
+              <a:t>├── tests/       82 tests (10 fichiers)</a:t>
             </a:r>
           </a:p>
           <a:p>

</xml_diff>